<commit_message>
docs(lesson-02): refine classroom questions and TA demo
</commit_message>
<xml_diff>
--- a/lessons/lesson-02/slides.pptx
+++ b/lessons/lesson-02/slides.pptx
@@ -863,7 +863,7 @@
                 <a:ea typeface="微软雅黑"/>
                 <a:cs typeface="微软雅黑"/>
               </a:rPr>
-              <a:t>避免羞辱或不切实际的追责；强调透明和按规则协调。</a:t>
+              <a:t>用虚构情境提问，不要求学生公开本人经历。先停止进一步发送、保留可核对记录，再按适用规则评估和沟通。</a:t>
             </a:r>
           </a:p>
           <a:p xmlns:a="http://schemas.openxmlformats.org/drawingml/2006/main">
@@ -902,7 +902,7 @@
                 <a:ea typeface="微软雅黑"/>
                 <a:cs typeface="微软雅黑"/>
               </a:rPr>
-              <a:t>选择恢复路径第一步</a:t>
+              <a:t>快答恢复路径的第一步</a:t>
             </a:r>
           </a:p>
           <a:p xmlns:a="http://schemas.openxmlformats.org/drawingml/2006/main">
@@ -1877,7 +1877,7 @@
                 <a:ea typeface="微软雅黑"/>
                 <a:cs typeface="微软雅黑"/>
               </a:rPr>
-              <a:t>这一页是全课唯一定义位；OpenCode 只是一个执行实例。</a:t>
+              <a:t>这一页是全课唯一定义位；Pi Agent 是课程主执行环境，OpenCode 等为备选。声明不自动成为强制限制，须由实际工具配置、权限扩展或隔离环境落实；Pi 默认没有逐次权限弹窗。</a:t>
             </a:r>
           </a:p>
           <a:p xmlns:a="http://schemas.openxmlformats.org/drawingml/2006/main">
@@ -2930,7 +2930,7 @@
                 <a:ea typeface="微软雅黑"/>
                 <a:cs typeface="微软雅黑"/>
               </a:rPr>
-              <a:t>圈出过宽配置的第一处风险</a:t>
+              <a:t>快答过宽配置的第一处风险及收窄方式</a:t>
             </a:r>
           </a:p>
           <a:p xmlns:a="http://schemas.openxmlformats.org/drawingml/2006/main">
@@ -4243,7 +4243,7 @@
                 <a:ea typeface="微软雅黑"/>
                 <a:cs typeface="微软雅黑"/>
               </a:rPr>
-              <a:t>不重复八阶段，只指出记录中的缺口。</a:t>
+              <a:t>回看第 1 课助教用 MI 课题完成的有限写回：diff 和日志说明文件发生了什么变化，材料身份、授权与外发条件仍需单独判断。这里回顾研究动作，不展示助教真实未发表材料。</a:t>
             </a:r>
           </a:p>
           <a:p xmlns:a="http://schemas.openxmlformats.org/drawingml/2006/main">
@@ -4620,7 +4620,7 @@
                 <a:ea typeface="微软雅黑"/>
                 <a:cs typeface="微软雅黑"/>
               </a:rPr>
-              <a:t>页面：P20 教师演示：风险与权限如何落地</a:t>
+              <a:t>页面：P20 助教演示：风险与权限如何落地</a:t>
             </a:r>
           </a:p>
           <a:p xmlns:a="http://schemas.openxmlformats.org/drawingml/2006/main">
@@ -4685,7 +4685,7 @@
                 <a:ea typeface="微软雅黑"/>
                 <a:cs typeface="微软雅黑"/>
               </a:rPr>
-              <a:t>教师演示 · 同一未公开合作稿案例；选择替代输入；只读边界审查；人工确认写回；核对三件工件；原稿不对 Agent 开放 / 改用抽象问题；检查过宽权限 / 与缺失的确认点；明确三份文件 / 及各自修改范围；风险卡、权限行 / 使用记录相互一致</a:t>
+              <a:t>助教演示 · 同一未公开合作稿案例；选择替代输入；只读边界审查；人工确认写回；核对三件工件；原稿不对 Agent 开放 / 改用抽象问题；检查过宽权限 / 与缺失的确认点；明确三份文件 / 及各自修改范围；风险卡、权限行 / 使用记录相互一致</a:t>
             </a:r>
           </a:p>
           <a:p xmlns:a="http://schemas.openxmlformats.org/drawingml/2006/main">
@@ -4724,7 +4724,7 @@
                 <a:ea typeface="微软雅黑"/>
                 <a:cs typeface="微软雅黑"/>
               </a:rPr>
-              <a:t>从 P03 的虚构未公开合作稿继续，不更换案例。用抽象问题或经授权公开版本完成替代路径，不教 OpenCode 菜单。</a:t>
+              <a:t>从 P03 的虚构合作稿继续。助教打开可恢复副本并操作；我来提问、判断和批准写回。上节助教以真实 MI 研究动作作示范，本节的稿件与记录均为课堂构造，不使用真实未发表材料。用抽象问题或经授权公开版本完成替代路径，不教 Pi Agent 菜单。</a:t>
             </a:r>
           </a:p>
           <a:p xmlns:a="http://schemas.openxmlformats.org/drawingml/2006/main">
@@ -5023,7 +5023,7 @@
                 <a:ea typeface="微软雅黑"/>
                 <a:cs typeface="微软雅黑"/>
               </a:rPr>
-              <a:t>教师演示 · 任务契约；第一轮；READ    agent-permissions.md；TASK    指出一处过宽或缺失权限；WRITE   none；NETWORK off；RETURN  建议、风险与最小替代动作；STOP    等待人工确认；研究者检查；建议收窄了范围， / 还是隐含扩大了 / 读写与外发权限？</a:t>
+              <a:t>助教演示 · 任务契约；第一轮；READ    agent-permissions.md；TASK    指出一处过宽或缺失权限；WRITE   none；NETWORK off；RETURN  建议、风险与最小替代动作；STOP    等待人工确认；研究者检查；建议收窄了范围， / 还是隐含扩大了 / 读写与外发权限？</a:t>
             </a:r>
           </a:p>
           <a:p xmlns:a="http://schemas.openxmlformats.org/drawingml/2006/main">
@@ -5062,7 +5062,7 @@
                 <a:ea typeface="微软雅黑"/>
                 <a:cs typeface="微软雅黑"/>
               </a:rPr>
-              <a:t>让 Agent 只读权限矩阵，指出一处过宽或缺失，不允许写。</a:t>
+              <a:t>助教展示只读检查的实际输入和返回建议后停下。请学生指出哪一项权限被收窄；若建议暗含新文件或外发权限，先拒绝并改写边界。确认当前未写文件，再进入下一页。</a:t>
             </a:r>
           </a:p>
           <a:p xmlns:a="http://schemas.openxmlformats.org/drawingml/2006/main">
@@ -5361,7 +5361,7 @@
                 <a:ea typeface="微软雅黑"/>
                 <a:cs typeface="微软雅黑"/>
               </a:rPr>
-              <a:t>教师演示 · 任务契约；第二轮：只写回获批范围；WRITE   agent-permissions.md 一行；ethics-and-compliance.md 风险卡；ai-usage-log.md 一条记录；KEEP    问题、指标与工件状态；NETWORK off；AFTER   展示实际 diff；确认点；文件 / 段落 / 修改范围</a:t>
+              <a:t>助教演示 · 任务契约；第二轮：只写回获批范围；WRITE   agent-permissions.md 一行；ethics-and-compliance.md 风险卡；ai-usage-log.md 一条记录；KEEP    问题、指标与工件状态；NETWORK off；AFTER   展示实际 diff；确认点；文件 / 段落 / 修改范围</a:t>
             </a:r>
           </a:p>
           <a:p xmlns:a="http://schemas.openxmlformats.org/drawingml/2006/main">
@@ -5400,7 +5400,7 @@
                 <a:ea typeface="微软雅黑"/>
                 <a:cs typeface="微软雅黑"/>
               </a:rPr>
-              <a:t>风险卡写清原稿为何不外发；权限行只授权替代输入；日志记录原稿未发送与实际核验。不在课堂演示额外工件追踪填表。</a:t>
+              <a:t>我明确批准三份文件的目标段落和修改范围，助教才写回。风险卡写清原稿为何不外发；权限行只授权替代输入；日志记录原稿未发送与实际核验。打开实际 diff，请学生查有无越界、三份记录是否指向同一动作；不在课堂演示额外工件追踪填表。若限制配置未在授课设备通过复演，助教改用预制 diff 并标明回放。</a:t>
             </a:r>
           </a:p>
           <a:p xmlns:a="http://schemas.openxmlformats.org/drawingml/2006/main">
@@ -5439,7 +5439,7 @@
                 <a:ea typeface="微软雅黑"/>
                 <a:cs typeface="微软雅黑"/>
               </a:rPr>
-              <a:t>检查实际修改文件是否超出三项</a:t>
+              <a:t>检查实际 diff 是否只含获批三项，指出一处人工核验依据</a:t>
             </a:r>
           </a:p>
           <a:p xmlns:a="http://schemas.openxmlformats.org/drawingml/2006/main">
@@ -7090,7 +7090,7 @@
                 <a:ea typeface="微软雅黑"/>
                 <a:cs typeface="微软雅黑"/>
               </a:rPr>
-              <a:t>就当前信息，不可上传原稿：缺共同作者授权和平台条款核对。“有条件允许”只描述补齐条件后的新情境，不表示现在可先发。完成判断后切换到公开构造材料，继续示范风险卡与授权边界。</a:t>
+              <a:t>此处开始使用与助教真实 MI 课题分开的虚构合作稿。就当前信息，不可上传原稿：缺共同作者授权和平台条款核对。“有条件允许”只描述补齐条件后的新情境，不表示现在可先发。完成判断后切换到公开构造材料，继续示范风险卡与授权边界。先让每人选一档，再请邻座互述一个决定性条件，最后收束。</a:t>
             </a:r>
           </a:p>
           <a:p xmlns:a="http://schemas.openxmlformats.org/drawingml/2006/main">
@@ -21001,7 +21001,7 @@
                 <a:ea typeface="微软雅黑"/>
                 <a:cs typeface="微软雅黑"/>
               </a:rPr>
-              <a:t>教师演示：风险与权限如何落地</a:t>
+              <a:t>助教演示：风险与权限如何落地</a:t>
             </a:r>
           </a:p>
         </p:txBody>
@@ -21112,7 +21112,7 @@
                 <a:ea typeface="微软雅黑"/>
                 <a:cs typeface="微软雅黑"/>
               </a:rPr>
-              <a:t>教师演示 · 同一未公开合作稿案例</a:t>
+              <a:t>助教演示 · 同一未公开合作稿案例</a:t>
             </a:r>
           </a:p>
         </p:txBody>
@@ -21985,7 +21985,7 @@
                 <a:ea typeface="微软雅黑"/>
                 <a:cs typeface="微软雅黑"/>
               </a:rPr>
-              <a:t>教师演示 · 任务契约</a:t>
+              <a:t>助教演示 · 任务契约</a:t>
             </a:r>
           </a:p>
         </p:txBody>
@@ -22801,7 +22801,7 @@
                 <a:ea typeface="微软雅黑"/>
                 <a:cs typeface="微软雅黑"/>
               </a:rPr>
-              <a:t>教师演示 · 任务契约</a:t>
+              <a:t>助教演示 · 任务契约</a:t>
             </a:r>
           </a:p>
         </p:txBody>

</xml_diff>